<commit_message>
psf changes and optical sectioning
</commit_message>
<xml_diff>
--- a/figures/resources/spherical_aberrations.pptx
+++ b/figures/resources/spherical_aberrations.pptx
@@ -198,7 +198,7 @@
           <a:p>
             <a:fld id="{57CE18C3-BE54-304B-9A76-EE02D04C62D1}" type="datetimeFigureOut">
               <a:rPr lang="en-DE" smtClean="0"/>
-              <a:t>23.04.26</a:t>
+              <a:t>24.04.26</a:t>
             </a:fld>
             <a:endParaRPr lang="en-DE"/>
           </a:p>
@@ -615,7 +615,7 @@
           <a:p>
             <a:fld id="{B7756873-501F-A744-AAAE-0CDF6C6A3E0B}" type="datetimeFigureOut">
               <a:rPr lang="en-DE" smtClean="0"/>
-              <a:t>23.04.26</a:t>
+              <a:t>24.04.26</a:t>
             </a:fld>
             <a:endParaRPr lang="en-DE"/>
           </a:p>
@@ -815,7 +815,7 @@
           <a:p>
             <a:fld id="{B7756873-501F-A744-AAAE-0CDF6C6A3E0B}" type="datetimeFigureOut">
               <a:rPr lang="en-DE" smtClean="0"/>
-              <a:t>23.04.26</a:t>
+              <a:t>24.04.26</a:t>
             </a:fld>
             <a:endParaRPr lang="en-DE"/>
           </a:p>
@@ -1025,7 +1025,7 @@
           <a:p>
             <a:fld id="{B7756873-501F-A744-AAAE-0CDF6C6A3E0B}" type="datetimeFigureOut">
               <a:rPr lang="en-DE" smtClean="0"/>
-              <a:t>23.04.26</a:t>
+              <a:t>24.04.26</a:t>
             </a:fld>
             <a:endParaRPr lang="en-DE"/>
           </a:p>
@@ -1225,7 +1225,7 @@
           <a:p>
             <a:fld id="{B7756873-501F-A744-AAAE-0CDF6C6A3E0B}" type="datetimeFigureOut">
               <a:rPr lang="en-DE" smtClean="0"/>
-              <a:t>23.04.26</a:t>
+              <a:t>24.04.26</a:t>
             </a:fld>
             <a:endParaRPr lang="en-DE"/>
           </a:p>
@@ -1501,7 +1501,7 @@
           <a:p>
             <a:fld id="{B7756873-501F-A744-AAAE-0CDF6C6A3E0B}" type="datetimeFigureOut">
               <a:rPr lang="en-DE" smtClean="0"/>
-              <a:t>23.04.26</a:t>
+              <a:t>24.04.26</a:t>
             </a:fld>
             <a:endParaRPr lang="en-DE"/>
           </a:p>
@@ -1769,7 +1769,7 @@
           <a:p>
             <a:fld id="{B7756873-501F-A744-AAAE-0CDF6C6A3E0B}" type="datetimeFigureOut">
               <a:rPr lang="en-DE" smtClean="0"/>
-              <a:t>23.04.26</a:t>
+              <a:t>24.04.26</a:t>
             </a:fld>
             <a:endParaRPr lang="en-DE"/>
           </a:p>
@@ -2184,7 +2184,7 @@
           <a:p>
             <a:fld id="{B7756873-501F-A744-AAAE-0CDF6C6A3E0B}" type="datetimeFigureOut">
               <a:rPr lang="en-DE" smtClean="0"/>
-              <a:t>23.04.26</a:t>
+              <a:t>24.04.26</a:t>
             </a:fld>
             <a:endParaRPr lang="en-DE"/>
           </a:p>
@@ -2326,7 +2326,7 @@
           <a:p>
             <a:fld id="{B7756873-501F-A744-AAAE-0CDF6C6A3E0B}" type="datetimeFigureOut">
               <a:rPr lang="en-DE" smtClean="0"/>
-              <a:t>23.04.26</a:t>
+              <a:t>24.04.26</a:t>
             </a:fld>
             <a:endParaRPr lang="en-DE"/>
           </a:p>
@@ -2439,7 +2439,7 @@
           <a:p>
             <a:fld id="{B7756873-501F-A744-AAAE-0CDF6C6A3E0B}" type="datetimeFigureOut">
               <a:rPr lang="en-DE" smtClean="0"/>
-              <a:t>23.04.26</a:t>
+              <a:t>24.04.26</a:t>
             </a:fld>
             <a:endParaRPr lang="en-DE"/>
           </a:p>
@@ -2752,7 +2752,7 @@
           <a:p>
             <a:fld id="{B7756873-501F-A744-AAAE-0CDF6C6A3E0B}" type="datetimeFigureOut">
               <a:rPr lang="en-DE" smtClean="0"/>
-              <a:t>23.04.26</a:t>
+              <a:t>24.04.26</a:t>
             </a:fld>
             <a:endParaRPr lang="en-DE"/>
           </a:p>
@@ -3041,7 +3041,7 @@
           <a:p>
             <a:fld id="{B7756873-501F-A744-AAAE-0CDF6C6A3E0B}" type="datetimeFigureOut">
               <a:rPr lang="en-DE" smtClean="0"/>
-              <a:t>23.04.26</a:t>
+              <a:t>24.04.26</a:t>
             </a:fld>
             <a:endParaRPr lang="en-DE"/>
           </a:p>
@@ -3284,7 +3284,7 @@
           <a:p>
             <a:fld id="{B7756873-501F-A744-AAAE-0CDF6C6A3E0B}" type="datetimeFigureOut">
               <a:rPr lang="en-DE" smtClean="0"/>
-              <a:t>23.04.26</a:t>
+              <a:t>24.04.26</a:t>
             </a:fld>
             <a:endParaRPr lang="en-DE"/>
           </a:p>
@@ -3877,8 +3877,8 @@
             </a:p>
           </p:txBody>
         </p:sp>
-        <mc:AlternateContent xmlns:mc="http://schemas.openxmlformats.org/markup-compatibility/2006">
-          <mc:Choice xmlns:a14="http://schemas.microsoft.com/office/drawing/2010/main" Requires="a14">
+        <mc:AlternateContent xmlns:mc="http://schemas.openxmlformats.org/markup-compatibility/2006" xmlns:a14="http://schemas.microsoft.com/office/drawing/2010/main">
+          <mc:Choice Requires="a14">
             <p:sp>
               <p:nvSpPr>
                 <p:cNvPr id="6" name="TextBox 5">
@@ -4017,16 +4017,7 @@
                                 </a:solidFill>
                                 <a:latin typeface="Cambria Math" panose="02040503050406030204" pitchFamily="18" charset="0"/>
                               </a:rPr>
-                              <m:t>𝑀𝑜𝑢𝑛</m:t>
-                            </m:r>
-                            <m:r>
-                              <a:rPr lang="en-US" sz="1400" b="0" i="1" smtClean="0">
-                                <a:solidFill>
-                                  <a:schemeClr val="bg1"/>
-                                </a:solidFill>
-                                <a:latin typeface="Cambria Math" panose="02040503050406030204" pitchFamily="18" charset="0"/>
-                              </a:rPr>
-                              <m:t>𝑡</m:t>
+                              <m:t>𝑀𝑜𝑢𝑛𝑡</m:t>
                             </m:r>
                           </m:sub>
                         </m:sSub>
@@ -4088,7 +4079,7 @@
               </p:txBody>
             </p:sp>
           </mc:Choice>
-          <mc:Fallback>
+          <mc:Fallback xmlns="">
             <p:sp>
               <p:nvSpPr>
                 <p:cNvPr id="6" name="TextBox 5">
@@ -4283,8 +4274,8 @@
             </a:p>
           </p:txBody>
         </p:sp>
-        <mc:AlternateContent xmlns:mc="http://schemas.openxmlformats.org/markup-compatibility/2006">
-          <mc:Choice xmlns:a14="http://schemas.microsoft.com/office/drawing/2010/main" Requires="a14">
+        <mc:AlternateContent xmlns:mc="http://schemas.openxmlformats.org/markup-compatibility/2006" xmlns:a14="http://schemas.microsoft.com/office/drawing/2010/main">
+          <mc:Choice Requires="a14">
             <p:sp>
               <p:nvSpPr>
                 <p:cNvPr id="10" name="TextBox 9">
@@ -4423,16 +4414,7 @@
                                 </a:solidFill>
                                 <a:latin typeface="Cambria Math" panose="02040503050406030204" pitchFamily="18" charset="0"/>
                               </a:rPr>
-                              <m:t>𝑀𝑜𝑢</m:t>
-                            </m:r>
-                            <m:r>
-                              <a:rPr lang="en-US" sz="1400" b="0" i="1" smtClean="0">
-                                <a:solidFill>
-                                  <a:schemeClr val="bg1"/>
-                                </a:solidFill>
-                                <a:latin typeface="Cambria Math" panose="02040503050406030204" pitchFamily="18" charset="0"/>
-                              </a:rPr>
-                              <m:t>𝑡</m:t>
+                              <m:t>𝑀𝑜𝑢𝑡</m:t>
                             </m:r>
                           </m:sub>
                         </m:sSub>
@@ -4494,7 +4476,7 @@
               </p:txBody>
             </p:sp>
           </mc:Choice>
-          <mc:Fallback>
+          <mc:Fallback xmlns="">
             <p:sp>
               <p:nvSpPr>
                 <p:cNvPr id="10" name="TextBox 9">
@@ -4863,8 +4845,8 @@
             </p:txBody>
           </p:sp>
         </p:grpSp>
-        <mc:AlternateContent xmlns:mc="http://schemas.openxmlformats.org/markup-compatibility/2006">
-          <mc:Choice xmlns:a14="http://schemas.microsoft.com/office/drawing/2010/main" Requires="a14">
+        <mc:AlternateContent xmlns:mc="http://schemas.openxmlformats.org/markup-compatibility/2006" xmlns:a14="http://schemas.microsoft.com/office/drawing/2010/main">
+          <mc:Choice Requires="a14">
             <p:sp>
               <p:nvSpPr>
                 <p:cNvPr id="38" name="TextBox 37">
@@ -5003,16 +4985,7 @@
                                 </a:solidFill>
                                 <a:latin typeface="Cambria Math" panose="02040503050406030204" pitchFamily="18" charset="0"/>
                               </a:rPr>
-                              <m:t>𝑀𝑜𝑢</m:t>
-                            </m:r>
-                            <m:r>
-                              <a:rPr lang="en-US" sz="1400" b="0" i="1" smtClean="0">
-                                <a:solidFill>
-                                  <a:schemeClr val="bg1"/>
-                                </a:solidFill>
-                                <a:latin typeface="Cambria Math" panose="02040503050406030204" pitchFamily="18" charset="0"/>
-                              </a:rPr>
-                              <m:t>𝑛𝑡</m:t>
+                              <m:t>𝑀𝑜𝑢𝑛𝑡</m:t>
                             </m:r>
                           </m:sub>
                         </m:sSub>
@@ -5074,7 +5047,7 @@
               </p:txBody>
             </p:sp>
           </mc:Choice>
-          <mc:Fallback>
+          <mc:Fallback xmlns="">
             <p:sp>
               <p:nvSpPr>
                 <p:cNvPr id="38" name="TextBox 37">
@@ -5203,8 +5176,8 @@
           </p:nvSpPr>
           <p:spPr>
             <a:xfrm>
-              <a:off x="8722579" y="5817346"/>
-              <a:ext cx="1583640" cy="430255"/>
+              <a:off x="8805290" y="5822853"/>
+              <a:ext cx="1780375" cy="430255"/>
             </a:xfrm>
             <a:prstGeom prst="rect">
               <a:avLst/>
@@ -5252,8 +5225,8 @@
         </p:nvGrpSpPr>
         <p:grpSpPr>
           <a:xfrm>
-            <a:off x="6483441" y="3965301"/>
-            <a:ext cx="3197236" cy="2801275"/>
+            <a:off x="4324082" y="3902708"/>
+            <a:ext cx="2899182" cy="2540133"/>
             <a:chOff x="6409334" y="277885"/>
             <a:chExt cx="3197236" cy="2801275"/>
           </a:xfrm>
@@ -5628,6 +5601,37 @@
           </a:p>
         </p:txBody>
       </p:sp>
+      <p:pic>
+        <p:nvPicPr>
+          <p:cNvPr id="2" name="Picture 1">
+            <a:extLst>
+              <a:ext uri="{FF2B5EF4-FFF2-40B4-BE49-F238E27FC236}">
+                <a16:creationId xmlns:a16="http://schemas.microsoft.com/office/drawing/2014/main" id="{1B3E0E57-028E-404C-859C-E7321A26DA40}"/>
+              </a:ext>
+            </a:extLst>
+          </p:cNvPr>
+          <p:cNvPicPr>
+            <a:picLocks noChangeAspect="1"/>
+          </p:cNvPicPr>
+          <p:nvPr/>
+        </p:nvPicPr>
+        <p:blipFill>
+          <a:blip r:embed="rId9"/>
+          <a:srcRect r="48522"/>
+          <a:stretch>
+            <a:fillRect/>
+          </a:stretch>
+        </p:blipFill>
+        <p:spPr>
+          <a:xfrm>
+            <a:off x="7346974" y="3718112"/>
+            <a:ext cx="2715758" cy="3232579"/>
+          </a:xfrm>
+          <a:prstGeom prst="rect">
+            <a:avLst/>
+          </a:prstGeom>
+        </p:spPr>
+      </p:pic>
     </p:spTree>
     <p:extLst>
       <p:ext uri="{BB962C8B-B14F-4D97-AF65-F5344CB8AC3E}">

</xml_diff>